<commit_message>
Finalize CardioSense AI: 7-model comparison, responsive UI, updated report/slides, viva Q&A
- Remove MLP; app, training script, CSV, README, report and slides now describe 7 models
- Responsive Streamlit layout; Threshold tab explains the illustrative 0.4/0.6 bands
- README, report: state browser-emulation-only testing, not deployed, no physical-device test
- Rebuild report DOCX/PDF and slides; add emulated phone/tablet/desktop screenshots
- Add VIVA_QA.md

Co-Authored-By: Claude Sonnet 5.5 <noreply@anthropic.com>
</commit_message>
<xml_diff>
--- a/CardioSense_AI_Presentation.pptx
+++ b/CardioSense_AI_Presentation.pptx
@@ -6489,7 +6489,7 @@
                 </a:solidFill>
                 <a:latin typeface="Aptos"/>
               </a:rPr>
-              <a:t>IMPORTANT: Educational prototype only. It must not be used to diagnose or rule out cardiovascular disease.</a:t>
+              <a:t>IMPORTANT: Educational prototype only. It must not be used to diagnose or rule out cardiovascular disease. Tested in browser emulation only; not deployed publicly.</a:t>
             </a:r>
           </a:p>
         </p:txBody>
@@ -9182,7 +9182,7 @@
                 </a:solidFill>
                 <a:latin typeface="Aptos"/>
               </a:rPr>
-              <a:t>Deploy a tool</a:t>
+              <a:t>Build a tool</a:t>
             </a:r>
           </a:p>
         </p:txBody>
@@ -9221,7 +9221,7 @@
                 </a:solidFill>
                 <a:latin typeface="Aptos"/>
               </a:rPr>
-              <a:t>Make a browser-based interface for model outputs.</a:t>
+              <a:t>Make a responsive browser interface for model outputs.</a:t>
             </a:r>
           </a:p>
         </p:txBody>
@@ -14875,7 +14875,7 @@
                 </a:solidFill>
                 <a:latin typeface="Aptos"/>
               </a:rPr>
-              <a:t>8 models</a:t>
+              <a:t>7 models</a:t>
             </a:r>
           </a:p>
         </p:txBody>
@@ -16289,7 +16289,7 @@
                 </a:solidFill>
                 <a:latin typeface="Aptos"/>
               </a:rPr>
-              <a:t>Models cover linear, distance-based, margin-based (SVM), tree-based (entropy), boosted and neural-network approaches.</a:t>
+              <a:t>Models cover linear, distance-based, margin-based (SVM), tree-based (entropy) and boosted approaches.</a:t>
             </a:r>
           </a:p>
         </p:txBody>
@@ -16588,7 +16588,7 @@
                 </a:solidFill>
                 <a:latin typeface="Aptos"/>
               </a:rPr>
-              <a:t>Eight models were trained on the same split; the strongest four are within 0.003 ROC-AUC.</a:t>
+              <a:t>Seven models were trained on the same split; the strongest three are within 0.001 ROC-AUC.</a:t>
             </a:r>
           </a:p>
         </p:txBody>
@@ -17029,7 +17029,7 @@
                 </a:solidFill>
                 <a:latin typeface="Aptos"/>
               </a:rPr>
-              <a:t>Source: project outputs/model_comparison.csv (8 models, same split).</a:t>
+              <a:t>Source: project outputs/model_comparison.csv (7 models, same split).</a:t>
             </a:r>
           </a:p>
         </p:txBody>
@@ -17156,15 +17156,15 @@
           <p:nvPr/>
         </p:nvPicPr>
         <p:blipFill>
-          <a:blip r:embed="rId3"/>
+          <a:blip r:embed="rId4"/>
           <a:stretch>
             <a:fillRect/>
           </a:stretch>
         </p:blipFill>
         <p:spPr>
           <a:xfrm>
-            <a:off x="804672" y="2228226"/>
-            <a:ext cx="6510528" cy="2959330"/>
+            <a:off x="804673" y="2228226"/>
+            <a:ext cx="6510526" cy="2959330"/>
           </a:xfrm>
           <a:prstGeom prst="rect">
             <a:avLst/>
@@ -21674,7 +21674,7 @@
         <p:spPr>
           <a:xfrm>
             <a:off x="7333488" y="5596128"/>
-            <a:ext cx="3749039" cy="219456"/>
+            <a:ext cx="3749039" cy="438912"/>
           </a:xfrm>
           <a:prstGeom prst="rect">
             <a:avLst/>
@@ -21699,7 +21699,23 @@
                 </a:solidFill>
                 <a:latin typeface="Aptos"/>
               </a:rPr>
-              <a:t>Run locally:  `python run.py`  •  Streamlit + joblib</a:t>
+              <a:t>Run locally:  `python -m streamlit run app/app.py`</a:t>
+            </a:r>
+          </a:p>
+          <a:p>
+            <a:pPr algn="l">
+              <a:lnSpc>
+                <a:spcPct val="100000"/>
+              </a:lnSpc>
+            </a:pPr>
+            <a:r>
+              <a:rPr sz="940" b="1" i="0">
+                <a:solidFill>
+                  <a:srgbClr val="087E78"/>
+                </a:solidFill>
+                <a:latin typeface="Aptos"/>
+              </a:rPr>
+              <a:t>Phone (same Wi-Fi):  add `--server.address 0.0.0.0`</a:t>
             </a:r>
           </a:p>
         </p:txBody>
@@ -21738,7 +21754,7 @@
                 </a:solidFill>
                 <a:latin typeface="Aptos"/>
               </a:rPr>
-              <a:t>The report does not include a deployed public URL; the supplied code supports local execution and Streamlit Community Cloud deployment.</a:t>
+              <a:t>Not deployed publicly; runs locally and on the same Wi-Fi. Layout tested in browser emulation at phone, tablet and desktop sizes, not on physical devices.</a:t>
             </a:r>
           </a:p>
         </p:txBody>
@@ -21858,22 +21874,22 @@
       </p:sp>
       <p:pic>
         <p:nvPicPr>
-          <p:cNvPr id="31" name="Picture 30" descr="01_predict.png"/>
+          <p:cNvPr id="31" name="Picture 30" descr="slide9_three_views.png"/>
           <p:cNvPicPr>
             <a:picLocks noChangeAspect="1"/>
           </p:cNvPicPr>
           <p:nvPr/>
         </p:nvPicPr>
         <p:blipFill>
-          <a:blip r:embed="rId3"/>
+          <a:blip r:embed="rId5"/>
           <a:stretch>
             <a:fillRect/>
           </a:stretch>
         </p:blipFill>
         <p:spPr>
           <a:xfrm>
-            <a:off x="947363" y="1702647"/>
-            <a:ext cx="5457049" cy="4092786"/>
+            <a:off x="947363" y="2632347"/>
+            <a:ext cx="5457049" cy="2233386"/>
           </a:xfrm>
           <a:prstGeom prst="rect">
             <a:avLst/>

</xml_diff>

<commit_message>
Add live Streamlit Cloud URL to README, report, slides and viva Q&A
- Replace the deployment placeholder with https://cardiosense-risk-predictor.streamlit.app/
- State that the live site was checked in browser emulation only; no physical-device test
- Rebuild report PDF from the updated DOCX (10 pages)

Co-Authored-By: Claude Sonnet 5.5 <noreply@anthropic.com>
</commit_message>
<xml_diff>
--- a/CardioSense_AI_Presentation.pptx
+++ b/CardioSense_AI_Presentation.pptx
@@ -6489,7 +6489,7 @@
                 </a:solidFill>
                 <a:latin typeface="Aptos"/>
               </a:rPr>
-              <a:t>IMPORTANT: Educational prototype only. It must not be used to diagnose or rule out cardiovascular disease. Tested in browser emulation only; not deployed publicly.</a:t>
+              <a:t>IMPORTANT: Educational prototype only. It must not be used to diagnose or rule out cardiovascular disease. Tested in browser emulation only; deployed on Streamlit Community Cloud.</a:t>
             </a:r>
           </a:p>
         </p:txBody>
@@ -21754,7 +21754,7 @@
                 </a:solidFill>
                 <a:latin typeface="Aptos"/>
               </a:rPr>
-              <a:t>Not deployed publicly; runs locally and on the same Wi-Fi. Layout tested in browser emulation at phone, tablet and desktop sizes, not on physical devices.</a:t>
+              <a:t>Live: https://cardiosense-risk-predictor.streamlit.app/ (Streamlit Community Cloud). Layout tested in browser emulation at phone, tablet and desktop sizes, not on physical devices.</a:t>
             </a:r>
           </a:p>
         </p:txBody>

</xml_diff>